<commit_message>
Actualizar diapositivas con los numeros corregidos de P8 (auditoria de reproducibilidad)
Las diapositivas 22, 23 y 29 citaban los valores de percolacion de nodos,
eficiencia global y el resumen de cierre con los numeros de la version
anterior a la correccion de eb638b6 (single-shot sin promediar). Se
actualizan las 3 diapositivas para que coincidan exactamente con
informe.tex y los CSV de analisis/resultados/:

- Diapositiva 22 (P8.1-8.3): f_c aleatorio 0,237->0,243, nodos 42->43,
  S(f=0,05) de las tres estrategias dirigidas.
- Diapositiva 23 (P8.4): tabla de eficiencia E(f)/E(0) bajo fallo
  aleatorio, ahora promediada sobre 20 realizaciones.
- Diapositiva 29 (cierre): f_c 0,237->0,243.

La diapositiva 11 (P2, modelos nulos) no se toca: ya promediaba
correctamente sobre 100 realizaciones antes de esta auditoria, y sus
cifras siguen coincidiendo con informe.tex.
</commit_message>
<xml_diff>
--- a/diapositivas/Presentacion_Redes_Complejas_RedUCuenca.pptx
+++ b/diapositivas/Presentacion_Redes_Complejas_RedUCuenca.pptx
@@ -20836,7 +20836,7 @@
                 <a:ea typeface="Cambria" pitchFamily="34" charset="-122"/>
                 <a:cs typeface="Cambria" pitchFamily="34" charset="-120"/>
               </a:rPr>
-              <a:t>Robusta al azar, frágil al ataque: 42 nodos contra 4</a:t>
+              <a:t>Robusta al azar, frágil al ataque: 43 nodos contra 4</a:t>
             </a:r>
             <a:endParaRPr lang="en-US" sz="3000" dirty="0"/>
           </a:p>
@@ -21290,7 +21290,7 @@
                           <a:ea typeface="Calibri" pitchFamily="34" charset="-122"/>
                           <a:cs typeface="Calibri" pitchFamily="34" charset="-120"/>
                         </a:rPr>
-                        <a:t>0,237</a:t>
+                        <a:t>0,243</a:t>
                       </a:r>
                       <a:endParaRPr lang="en-US" sz="1100" dirty="0">
                         <a:latin typeface="Calibri" charset="0"/>
@@ -21355,7 +21355,7 @@
                           <a:ea typeface="Calibri" pitchFamily="34" charset="-122"/>
                           <a:cs typeface="Calibri" pitchFamily="34" charset="-120"/>
                         </a:rPr>
-                        <a:t>42</a:t>
+                        <a:t>43</a:t>
                       </a:r>
                       <a:endParaRPr lang="en-US" sz="1100" dirty="0">
                         <a:latin typeface="Calibri" charset="0"/>
@@ -21682,7 +21682,7 @@
                           <a:ea typeface="Calibri" pitchFamily="34" charset="-122"/>
                           <a:cs typeface="Calibri" pitchFamily="34" charset="-120"/>
                         </a:rPr>
-                        <a:t>0,381</a:t>
+                        <a:t>0,373</a:t>
                       </a:r>
                       <a:endParaRPr lang="en-US" sz="1100" dirty="0">
                         <a:latin typeface="Calibri" charset="0"/>
@@ -21944,7 +21944,7 @@
                           <a:ea typeface="Calibri" pitchFamily="34" charset="-122"/>
                           <a:cs typeface="Calibri" pitchFamily="34" charset="-120"/>
                         </a:rPr>
-                        <a:t>0,212</a:t>
+                        <a:t>0,198</a:t>
                       </a:r>
                       <a:endParaRPr lang="en-US" sz="1100" dirty="0">
                         <a:latin typeface="Calibri" charset="0"/>
@@ -22206,7 +22206,7 @@
                           <a:ea typeface="Calibri" pitchFamily="34" charset="-122"/>
                           <a:cs typeface="Calibri" pitchFamily="34" charset="-120"/>
                         </a:rPr>
-                        <a:t>0,053</a:t>
+                        <a:t>0,051</a:t>
                       </a:r>
                       <a:endParaRPr lang="en-US" sz="1100" dirty="0">
                         <a:latin typeface="Calibri" charset="0"/>
@@ -22388,7 +22388,7 @@
                 <a:ea typeface="Calibri" pitchFamily="34" charset="-122"/>
                 <a:cs typeface="Calibri" pitchFamily="34" charset="-120"/>
               </a:rPr>
-              <a:t>Un plan de RESPUESTA A INCIDENTES DE SEGURIDAD no puede asumir eso. Un atacante colapsa la red con 4 bajas dirigidas en vez de 42 al azar.</a:t>
+              <a:t>Un plan de RESPUESTA A INCIDENTES DE SEGURIDAD no puede asumir eso. Un atacante colapsa la red con 4 bajas dirigidas en vez de 43 al azar.</a:t>
             </a:r>
             <a:endParaRPr lang="en-US" sz="1200" dirty="0"/>
           </a:p>
@@ -23080,7 +23080,7 @@
                           <a:ea typeface="Calibri" pitchFamily="34" charset="-122"/>
                           <a:cs typeface="Calibri" pitchFamily="34" charset="-120"/>
                         </a:rPr>
-                        <a:t>0,959</a:t>
+                        <a:t>0,901</a:t>
                       </a:r>
                       <a:endParaRPr lang="en-US" sz="1100" dirty="0">
                         <a:latin typeface="Calibri" charset="0"/>
@@ -23145,7 +23145,7 @@
                           <a:ea typeface="Calibri" pitchFamily="34" charset="-122"/>
                           <a:cs typeface="Calibri" pitchFamily="34" charset="-120"/>
                         </a:rPr>
-                        <a:t>0,785</a:t>
+                        <a:t>0,782</a:t>
                       </a:r>
                       <a:endParaRPr lang="en-US" sz="1100" dirty="0">
                         <a:latin typeface="Calibri" charset="0"/>
@@ -23210,7 +23210,7 @@
                           <a:ea typeface="Calibri" pitchFamily="34" charset="-122"/>
                           <a:cs typeface="Calibri" pitchFamily="34" charset="-120"/>
                         </a:rPr>
-                        <a:t>0,598</a:t>
+                        <a:t>0,644</a:t>
                       </a:r>
                       <a:endParaRPr lang="en-US" sz="1100" dirty="0">
                         <a:latin typeface="Calibri" charset="0"/>
@@ -23275,7 +23275,7 @@
                           <a:ea typeface="Calibri" pitchFamily="34" charset="-122"/>
                           <a:cs typeface="Calibri" pitchFamily="34" charset="-120"/>
                         </a:rPr>
-                        <a:t>0,388</a:t>
+                        <a:t>0,409</a:t>
                       </a:r>
                       <a:endParaRPr lang="en-US" sz="1100" dirty="0">
                         <a:latin typeface="Calibri" charset="0"/>
@@ -23407,7 +23407,7 @@
                           <a:ea typeface="Calibri" pitchFamily="34" charset="-122"/>
                           <a:cs typeface="Calibri" pitchFamily="34" charset="-120"/>
                         </a:rPr>
-                        <a:t>0,611</a:t>
+                        <a:t>0,580</a:t>
                       </a:r>
                       <a:endParaRPr lang="en-US" sz="1100" dirty="0">
                         <a:latin typeface="Calibri" charset="0"/>
@@ -23472,7 +23472,7 @@
                           <a:ea typeface="Calibri" pitchFamily="34" charset="-122"/>
                           <a:cs typeface="Calibri" pitchFamily="34" charset="-120"/>
                         </a:rPr>
-                        <a:t>0,148</a:t>
+                        <a:t>0,143</a:t>
                       </a:r>
                       <a:endParaRPr lang="en-US" sz="1100" dirty="0">
                         <a:latin typeface="Calibri" charset="0"/>
@@ -23537,7 +23537,7 @@
                           <a:ea typeface="Calibri" pitchFamily="34" charset="-122"/>
                           <a:cs typeface="Calibri" pitchFamily="34" charset="-120"/>
                         </a:rPr>
-                        <a:t>0,057</a:t>
+                        <a:t>0,051</a:t>
                       </a:r>
                       <a:endParaRPr lang="en-US" sz="1100" dirty="0">
                         <a:latin typeface="Calibri" charset="0"/>
@@ -37072,7 +37072,7 @@
                 <a:ea typeface="Calibri" pitchFamily="34" charset="-122"/>
                 <a:cs typeface="Calibri" pitchFamily="34" charset="-120"/>
               </a:rPr>
-              <a:t>f_c pasa de 0,237 (azar) a 0,023 (ataque). La eficiencia se degrada aún antes que la conectividad.</a:t>
+              <a:t>f_c pasa de 0,243 (azar) a 0,023 (ataque). La eficiencia se degrada aún antes que la conectividad.</a:t>
             </a:r>
             <a:endParaRPr lang="en-US" sz="1200" dirty="0"/>
           </a:p>

</xml_diff>

<commit_message>
informe+diapositivas: corrige conteo de candidatos con dano de capacidad (8->9)
Al resincronizar las guias de sustentacion externas contra el proyecto
final, un subagente recontó independientemente los candidatos de P9 que
superan 20% de dano de capacidad desde p9_tau_critico_por_nodo.csv y
obtuvo 9, no 8. Verificado de nuevo aqui con awk sobre el CSV: son
efectivamente 9 (incluye ROUTER-CAMPUS-PARAISO, tau_c_capacidad=0.03,
que el conteo original paso por alto). Error de conteo mio al redactar
la seccion de P9 en el commit anterior, no un problema del calculo.

Corrige las 3 ocurrencias en informe.tex (resumen ejecutivo, seccion P9,
conclusiones) y las 2 en las notas/texto de la lamina 14 de las
diapositivas. Informe recompilado con xelatex.

Co-Authored-By: Claude Sonnet 5 <noreply@anthropic.com>
</commit_message>
<xml_diff>
--- a/diapositivas/Presentacion_Redes_Complejas_RedUCuenca.pptx
+++ b/diapositivas/Presentacion_Redes_Complejas_RedUCuenca.pptx
@@ -1884,7 +1884,7 @@
           <a:p/>
           <a:p>
             <a:r>
-              <a:t>Pero probé un segundo criterio, deliberadamente distinto: fracción de CAPACIDAD, en Mbps, afectada. Y ahí la respuesta cambia: 8 de los 15 candidatos superan el 20 % de daño de capacidad, y en dos de ellos —nodos core y WAN— ese daño no baja del 20 % ni con el margen más generoso probado. La razón es mecánica: los candidatos a disparador son, por construcción, los nodos que concentran los enlaces troncales de 10 Gbps. Pocos nodos caen, pero si son del núcleo, se llevan buena parte del ancho de banda con pocas fichas. No contradice la conclusión original, la matiza: hace falta redundancia topológica, priorizada en el núcleo, no solo margen de capacidad genérico en toda la red.</a:t>
+              <a:t>Pero probé un segundo criterio, deliberadamente distinto: fracción de CAPACIDAD, en Mbps, afectada. Y ahí la respuesta cambia: 9 de los 15 candidatos superan el 20 % de daño de capacidad, y en dos de ellos —nodos core y WAN— ese daño no baja del 20 % ni con el margen más generoso probado. La razón es mecánica: los candidatos a disparador son, por construcción, los nodos que concentran los enlaces troncales de 10 Gbps. Pocos nodos caen, pero si son del núcleo, se llevan buena parte del ancho de banda con pocas fichas. No contradice la conclusión original, la matiza: hace falta redundancia topológica, priorizada en el núcleo, no solo margen de capacidad genérico en toda la red.</a:t>
             </a:r>
           </a:p>
           <a:p/>
@@ -10707,7 +10707,7 @@
                 <a:ea typeface="Calibri" pitchFamily="34" charset="-122"/>
                 <a:cs typeface="Calibri" pitchFamily="34" charset="-120"/>
               </a:rPr>
-              <a:t>Modelo de Motter-Lai (carga=intermediación, Cᵢ=(1+τ)Lᵢ, 13 valores de τ): con el criterio de NODOS, ningún nodo desencadena una cascada &gt;8,5 % de la red, ni con τ=0 — no hay τ_c positivo. Con un criterio ALTERNATIVO —fracción de CAPACIDAD (Mbps) afectada—, 8 de 15 candidatos superan 20 %, y en dos (core/WAN) el daño no baja de ese umbral ni con τ=1,0: pocos nodos caen, pero si son del núcleo, se llevan mucha capacidad.</a:t>
+              <a:t>Modelo de Motter-Lai (carga=intermediación, Cᵢ=(1+τ)Lᵢ, 13 valores de τ): con el criterio de NODOS, ningún nodo desencadena una cascada &gt;8,5 % de la red, ni con τ=0 — no hay τ_c positivo. Con un criterio ALTERNATIVO —fracción de CAPACIDAD (Mbps) afectada—, 9 de 15 candidatos superan 20 %, y en dos (core/WAN) el daño no baja de ese umbral ni con τ=1,0: pocos nodos caen, pero si son del núcleo, se llevan mucha capacidad.</a:t>
             </a:r>
             <a:endParaRPr lang="en-US" sz="1200" dirty="0"/>
           </a:p>

</xml_diff>